<commit_message>
Fit team slide to five profiles
Co-authored-by: arena-agent <297053741+arena-agent@users.noreply.github.com>
</commit_message>
<xml_diff>
--- a/pitch_deck/NeuroLink_Wear_Pitch_Deck.pptx
+++ b/pitch_deck/NeuroLink_Wear_Pitch_Deck.pptx
@@ -1563,12 +1563,17 @@
           <a:lstStyle/>
           <a:p>
             <a:r>
-              <a:t>One proof point per person — what each has shipped or published — beats a list of titles. Highlight the complementary split: embedded/product, AI/data, clinical, growth.</a:t>
-            </a:r>
-          </a:p>
-          <a:p>
-            <a:r>
-              <a:t>State the open seats as a strength: a geriatrics advisor and a partnerships lead are being recruited for the pilot phase, and part of the raise funds them.</a:t>
+              <a:t>The layout now accommodates five people. Replace card 3’s placeholder with the additional teammate’s name, role, photo and one shipped proof point. Keep the clinical advisor and growth lead clearly marked as recruiting until those seats are filled.</a:t>
+            </a:r>
+          </a:p>
+          <a:p>
+            <a:r>
+              <a:t>One proof point per person — what each has shipped or published — beats a list of titles. Highlight the complementary split: embedded/product, AI/data, and the fifth teammate’s actual specialty.</a:t>
+            </a:r>
+          </a:p>
+          <a:p>
+            <a:r>
+              <a:t>State the open advisor/partnership seats honestly and explain how the pilot plan will fill them.</a:t>
             </a:r>
           </a:p>
         </p:txBody>
@@ -24619,7 +24624,7 @@
                 </a:solidFill>
                 <a:latin typeface="Calibri"/>
               </a:rPr>
-              <a:t>Builders across embedded systems, data science and care — with advisors we are actively recruiting.</a:t>
+              <a:t>Five seats across embedded systems, data science, product and care — advisors marked as recruiting.</a:t>
             </a:r>
           </a:p>
         </p:txBody>
@@ -24632,12 +24637,12 @@
         </p:nvSpPr>
         <p:spPr>
           <a:xfrm>
-            <a:off x="548640" y="2103120"/>
-            <a:ext cx="2606040" cy="3200400"/>
+            <a:off x="502920" y="2103120"/>
+            <a:ext cx="2139696" cy="3310128"/>
           </a:xfrm>
           <a:prstGeom prst="roundRect">
             <a:avLst>
-              <a:gd name="adj" fmla="val 5614"/>
+              <a:gd name="adj" fmla="val 6837"/>
             </a:avLst>
           </a:prstGeom>
           <a:solidFill>
@@ -24676,8 +24681,8 @@
         </p:nvSpPr>
         <p:spPr>
           <a:xfrm>
-            <a:off x="822960" y="2331720"/>
-            <a:ext cx="822960" cy="822960"/>
+            <a:off x="1225295" y="2414016"/>
+            <a:ext cx="694944" cy="694944"/>
           </a:xfrm>
           <a:prstGeom prst="ellipse">
             <a:avLst/>
@@ -24718,8 +24723,8 @@
         </p:nvSpPr>
         <p:spPr>
           <a:xfrm>
-            <a:off x="822960" y="2331720"/>
-            <a:ext cx="822960" cy="822960"/>
+            <a:off x="1225295" y="2414016"/>
+            <a:ext cx="694944" cy="694944"/>
           </a:xfrm>
           <a:prstGeom prst="rect">
             <a:avLst/>
@@ -24741,7 +24746,7 @@
               </a:spcAft>
             </a:pPr>
             <a:r>
-              <a:rPr sz="1600" b="1" i="0">
+              <a:rPr sz="1300" b="1" i="0">
                 <a:solidFill>
                   <a:srgbClr val="FFFFFF"/>
                 </a:solidFill>
@@ -24760,8 +24765,8 @@
         </p:nvSpPr>
         <p:spPr>
           <a:xfrm>
-            <a:off x="822959" y="3383280"/>
-            <a:ext cx="2057400" cy="365760"/>
+            <a:off x="667512" y="3218688"/>
+            <a:ext cx="1810512" cy="438912"/>
           </a:xfrm>
           <a:prstGeom prst="rect">
             <a:avLst/>
@@ -24776,6 +24781,48 @@
           <a:p>
             <a:pPr algn="l">
               <a:lnSpc>
+                <a:spcPct val="100000"/>
+              </a:lnSpc>
+              <a:spcAft>
+                <a:spcPts val="0"/>
+              </a:spcAft>
+            </a:pPr>
+            <a:r>
+              <a:rPr sz="1140" b="1" i="0">
+                <a:solidFill>
+                  <a:srgbClr val="FFFFFF"/>
+                </a:solidFill>
+                <a:latin typeface="Calibri"/>
+              </a:rPr>
+              <a:t>Diaa Salah</a:t>
+            </a:r>
+          </a:p>
+        </p:txBody>
+      </p:sp>
+      <p:sp>
+        <p:nvSpPr>
+          <p:cNvPr id="8" name="TextBox 7"/>
+          <p:cNvSpPr txBox="1"/>
+          <p:nvPr/>
+        </p:nvSpPr>
+        <p:spPr>
+          <a:xfrm>
+            <a:off x="667512" y="3675887"/>
+            <a:ext cx="1810512" cy="576072"/>
+          </a:xfrm>
+          <a:prstGeom prst="rect">
+            <a:avLst/>
+          </a:prstGeom>
+          <a:noFill/>
+        </p:spPr>
+        <p:txBody>
+          <a:bodyPr wrap="square" lIns="0" rIns="0" tIns="0" bIns="0" anchor="t">
+            <a:noAutofit/>
+          </a:bodyPr>
+          <a:lstStyle/>
+          <a:p>
+            <a:pPr algn="l">
+              <a:lnSpc>
                 <a:spcPct val="108000"/>
               </a:lnSpc>
               <a:spcAft>
@@ -24783,27 +24830,27 @@
               </a:spcAft>
             </a:pPr>
             <a:r>
-              <a:rPr sz="1400" b="1" i="0">
-                <a:solidFill>
-                  <a:srgbClr val="FFFFFF"/>
-                </a:solidFill>
-                <a:latin typeface="Calibri"/>
-              </a:rPr>
-              <a:t>[Founder name]</a:t>
-            </a:r>
-          </a:p>
-        </p:txBody>
-      </p:sp>
-      <p:sp>
-        <p:nvSpPr>
-          <p:cNvPr id="8" name="TextBox 7"/>
-          <p:cNvSpPr txBox="1"/>
-          <p:nvPr/>
-        </p:nvSpPr>
-        <p:spPr>
-          <a:xfrm>
-            <a:off x="822959" y="3730752"/>
-            <a:ext cx="2057400" cy="548640"/>
+              <a:rPr sz="880" b="1" i="0">
+                <a:solidFill>
+                  <a:srgbClr val="6C3CE9"/>
+                </a:solidFill>
+                <a:latin typeface="Calibri"/>
+              </a:rPr>
+              <a:t>CEO · Product &amp; embedded systems</a:t>
+            </a:r>
+          </a:p>
+        </p:txBody>
+      </p:sp>
+      <p:sp>
+        <p:nvSpPr>
+          <p:cNvPr id="9" name="TextBox 8"/>
+          <p:cNvSpPr txBox="1"/>
+          <p:nvPr/>
+        </p:nvSpPr>
+        <p:spPr>
+          <a:xfrm>
+            <a:off x="667512" y="4315968"/>
+            <a:ext cx="1810512" cy="896112"/>
           </a:xfrm>
           <a:prstGeom prst="rect">
             <a:avLst/>
@@ -24818,56 +24865,14 @@
           <a:p>
             <a:pPr algn="l">
               <a:lnSpc>
-                <a:spcPct val="115000"/>
-              </a:lnSpc>
-              <a:spcAft>
-                <a:spcPts val="0"/>
-              </a:spcAft>
-            </a:pPr>
-            <a:r>
-              <a:rPr sz="1000" b="1" i="0">
-                <a:solidFill>
-                  <a:srgbClr val="6C3CE9"/>
-                </a:solidFill>
-                <a:latin typeface="Calibri"/>
-              </a:rPr>
-              <a:t>CEO · Product &amp; embedded systems</a:t>
-            </a:r>
-          </a:p>
-        </p:txBody>
-      </p:sp>
-      <p:sp>
-        <p:nvSpPr>
-          <p:cNvPr id="9" name="TextBox 8"/>
-          <p:cNvSpPr txBox="1"/>
-          <p:nvPr/>
-        </p:nvSpPr>
-        <p:spPr>
-          <a:xfrm>
-            <a:off x="822959" y="4297680"/>
-            <a:ext cx="2057400" cy="914400"/>
-          </a:xfrm>
-          <a:prstGeom prst="rect">
-            <a:avLst/>
-          </a:prstGeom>
-          <a:noFill/>
-        </p:spPr>
-        <p:txBody>
-          <a:bodyPr wrap="square" lIns="0" rIns="0" tIns="0" bIns="0" anchor="t">
-            <a:noAutofit/>
-          </a:bodyPr>
-          <a:lstStyle/>
-          <a:p>
-            <a:pPr algn="l">
-              <a:lnSpc>
-                <a:spcPct val="120000"/>
-              </a:lnSpc>
-              <a:spcAft>
-                <a:spcPts val="0"/>
-              </a:spcAft>
-            </a:pPr>
-            <a:r>
-              <a:rPr sz="1000" b="0" i="0">
+                <a:spcPct val="113000"/>
+              </a:lnSpc>
+              <a:spcAft>
+                <a:spcPts val="0"/>
+              </a:spcAft>
+            </a:pPr>
+            <a:r>
+              <a:rPr sz="880" b="0" i="0">
                 <a:solidFill>
                   <a:srgbClr val="A9A9C7"/>
                 </a:solidFill>
@@ -24886,12 +24891,12 @@
         </p:nvSpPr>
         <p:spPr>
           <a:xfrm>
-            <a:off x="3374136" y="2103120"/>
-            <a:ext cx="2606040" cy="3200400"/>
+            <a:off x="2807208" y="2103120"/>
+            <a:ext cx="2139696" cy="3310128"/>
           </a:xfrm>
           <a:prstGeom prst="roundRect">
             <a:avLst>
-              <a:gd name="adj" fmla="val 5614"/>
+              <a:gd name="adj" fmla="val 6837"/>
             </a:avLst>
           </a:prstGeom>
           <a:solidFill>
@@ -24930,8 +24935,8 @@
         </p:nvSpPr>
         <p:spPr>
           <a:xfrm>
-            <a:off x="3648455" y="2331720"/>
-            <a:ext cx="822960" cy="822960"/>
+            <a:off x="3529584" y="2414016"/>
+            <a:ext cx="694944" cy="694944"/>
           </a:xfrm>
           <a:prstGeom prst="ellipse">
             <a:avLst/>
@@ -24972,8 +24977,8 @@
         </p:nvSpPr>
         <p:spPr>
           <a:xfrm>
-            <a:off x="3648455" y="2331720"/>
-            <a:ext cx="822960" cy="822960"/>
+            <a:off x="3529584" y="2414016"/>
+            <a:ext cx="694944" cy="694944"/>
           </a:xfrm>
           <a:prstGeom prst="rect">
             <a:avLst/>
@@ -24995,7 +25000,7 @@
               </a:spcAft>
             </a:pPr>
             <a:r>
-              <a:rPr sz="1600" b="1" i="0">
+              <a:rPr sz="1300" b="1" i="0">
                 <a:solidFill>
                   <a:srgbClr val="FFFFFF"/>
                 </a:solidFill>
@@ -25014,8 +25019,8 @@
         </p:nvSpPr>
         <p:spPr>
           <a:xfrm>
-            <a:off x="3648456" y="3383280"/>
-            <a:ext cx="2057400" cy="365760"/>
+            <a:off x="2971800" y="3218688"/>
+            <a:ext cx="1810512" cy="438912"/>
           </a:xfrm>
           <a:prstGeom prst="rect">
             <a:avLst/>
@@ -25030,6 +25035,48 @@
           <a:p>
             <a:pPr algn="l">
               <a:lnSpc>
+                <a:spcPct val="100000"/>
+              </a:lnSpc>
+              <a:spcAft>
+                <a:spcPts val="0"/>
+              </a:spcAft>
+            </a:pPr>
+            <a:r>
+              <a:rPr sz="1140" b="1" i="0">
+                <a:solidFill>
+                  <a:srgbClr val="FFFFFF"/>
+                </a:solidFill>
+                <a:latin typeface="Calibri"/>
+              </a:rPr>
+              <a:t>[Co-founder name]</a:t>
+            </a:r>
+          </a:p>
+        </p:txBody>
+      </p:sp>
+      <p:sp>
+        <p:nvSpPr>
+          <p:cNvPr id="14" name="TextBox 13"/>
+          <p:cNvSpPr txBox="1"/>
+          <p:nvPr/>
+        </p:nvSpPr>
+        <p:spPr>
+          <a:xfrm>
+            <a:off x="2971800" y="3675887"/>
+            <a:ext cx="1810512" cy="576072"/>
+          </a:xfrm>
+          <a:prstGeom prst="rect">
+            <a:avLst/>
+          </a:prstGeom>
+          <a:noFill/>
+        </p:spPr>
+        <p:txBody>
+          <a:bodyPr wrap="square" lIns="0" rIns="0" tIns="0" bIns="0" anchor="t">
+            <a:noAutofit/>
+          </a:bodyPr>
+          <a:lstStyle/>
+          <a:p>
+            <a:pPr algn="l">
+              <a:lnSpc>
                 <a:spcPct val="108000"/>
               </a:lnSpc>
               <a:spcAft>
@@ -25037,27 +25084,27 @@
               </a:spcAft>
             </a:pPr>
             <a:r>
-              <a:rPr sz="1400" b="1" i="0">
-                <a:solidFill>
-                  <a:srgbClr val="FFFFFF"/>
-                </a:solidFill>
-                <a:latin typeface="Calibri"/>
-              </a:rPr>
-              <a:t>[Co-founder name]</a:t>
-            </a:r>
-          </a:p>
-        </p:txBody>
-      </p:sp>
-      <p:sp>
-        <p:nvSpPr>
-          <p:cNvPr id="14" name="TextBox 13"/>
-          <p:cNvSpPr txBox="1"/>
-          <p:nvPr/>
-        </p:nvSpPr>
-        <p:spPr>
-          <a:xfrm>
-            <a:off x="3648456" y="3730752"/>
-            <a:ext cx="2057400" cy="548640"/>
+              <a:rPr sz="880" b="1" i="0">
+                <a:solidFill>
+                  <a:srgbClr val="3B5BFF"/>
+                </a:solidFill>
+                <a:latin typeface="Calibri"/>
+              </a:rPr>
+              <a:t>CTO · AI &amp; data</a:t>
+            </a:r>
+          </a:p>
+        </p:txBody>
+      </p:sp>
+      <p:sp>
+        <p:nvSpPr>
+          <p:cNvPr id="15" name="TextBox 14"/>
+          <p:cNvSpPr txBox="1"/>
+          <p:nvPr/>
+        </p:nvSpPr>
+        <p:spPr>
+          <a:xfrm>
+            <a:off x="2971800" y="4315968"/>
+            <a:ext cx="1810512" cy="896112"/>
           </a:xfrm>
           <a:prstGeom prst="rect">
             <a:avLst/>
@@ -25072,56 +25119,14 @@
           <a:p>
             <a:pPr algn="l">
               <a:lnSpc>
-                <a:spcPct val="115000"/>
-              </a:lnSpc>
-              <a:spcAft>
-                <a:spcPts val="0"/>
-              </a:spcAft>
-            </a:pPr>
-            <a:r>
-              <a:rPr sz="1000" b="1" i="0">
-                <a:solidFill>
-                  <a:srgbClr val="3B5BFF"/>
-                </a:solidFill>
-                <a:latin typeface="Calibri"/>
-              </a:rPr>
-              <a:t>CTO · AI &amp; data</a:t>
-            </a:r>
-          </a:p>
-        </p:txBody>
-      </p:sp>
-      <p:sp>
-        <p:nvSpPr>
-          <p:cNvPr id="15" name="TextBox 14"/>
-          <p:cNvSpPr txBox="1"/>
-          <p:nvPr/>
-        </p:nvSpPr>
-        <p:spPr>
-          <a:xfrm>
-            <a:off x="3648456" y="4297680"/>
-            <a:ext cx="2057400" cy="914400"/>
-          </a:xfrm>
-          <a:prstGeom prst="rect">
-            <a:avLst/>
-          </a:prstGeom>
-          <a:noFill/>
-        </p:spPr>
-        <p:txBody>
-          <a:bodyPr wrap="square" lIns="0" rIns="0" tIns="0" bIns="0" anchor="t">
-            <a:noAutofit/>
-          </a:bodyPr>
-          <a:lstStyle/>
-          <a:p>
-            <a:pPr algn="l">
-              <a:lnSpc>
-                <a:spcPct val="120000"/>
-              </a:lnSpc>
-              <a:spcAft>
-                <a:spcPts val="0"/>
-              </a:spcAft>
-            </a:pPr>
-            <a:r>
-              <a:rPr sz="1000" b="0" i="0">
+                <a:spcPct val="113000"/>
+              </a:lnSpc>
+              <a:spcAft>
+                <a:spcPts val="0"/>
+              </a:spcAft>
+            </a:pPr>
+            <a:r>
+              <a:rPr sz="880" b="0" i="0">
                 <a:solidFill>
                   <a:srgbClr val="A9A9C7"/>
                 </a:solidFill>
@@ -25140,12 +25145,12 @@
         </p:nvSpPr>
         <p:spPr>
           <a:xfrm>
-            <a:off x="6199631" y="2103120"/>
-            <a:ext cx="2606040" cy="3200400"/>
+            <a:off x="5111496" y="2103120"/>
+            <a:ext cx="2139696" cy="3310128"/>
           </a:xfrm>
           <a:prstGeom prst="roundRect">
             <a:avLst>
-              <a:gd name="adj" fmla="val 5614"/>
+              <a:gd name="adj" fmla="val 6837"/>
             </a:avLst>
           </a:prstGeom>
           <a:solidFill>
@@ -25184,8 +25189,262 @@
         </p:nvSpPr>
         <p:spPr>
           <a:xfrm>
-            <a:off x="6473951" y="2331720"/>
-            <a:ext cx="822960" cy="822960"/>
+            <a:off x="5833872" y="2414016"/>
+            <a:ext cx="694944" cy="694944"/>
+          </a:xfrm>
+          <a:prstGeom prst="ellipse">
+            <a:avLst/>
+          </a:prstGeom>
+          <a:solidFill>
+            <a:srgbClr val="8B5CF6"/>
+          </a:solidFill>
+          <a:ln>
+            <a:noFill/>
+          </a:ln>
+          <a:effectLst/>
+        </p:spPr>
+        <p:style>
+          <a:lnRef idx="1">
+            <a:schemeClr val="accent1"/>
+          </a:lnRef>
+          <a:fillRef idx="3">
+            <a:schemeClr val="accent1"/>
+          </a:fillRef>
+          <a:effectRef idx="2">
+            <a:schemeClr val="accent1"/>
+          </a:effectRef>
+          <a:fontRef idx="minor">
+            <a:schemeClr val="lt1"/>
+          </a:fontRef>
+        </p:style>
+        <p:txBody>
+          <a:bodyPr rtlCol="0" anchor="ctr"/>
+          <a:lstStyle/>
+          <a:p/>
+        </p:txBody>
+      </p:sp>
+      <p:sp>
+        <p:nvSpPr>
+          <p:cNvPr id="18" name="TextBox 17"/>
+          <p:cNvSpPr txBox="1"/>
+          <p:nvPr/>
+        </p:nvSpPr>
+        <p:spPr>
+          <a:xfrm>
+            <a:off x="5833872" y="2414016"/>
+            <a:ext cx="694944" cy="694944"/>
+          </a:xfrm>
+          <a:prstGeom prst="rect">
+            <a:avLst/>
+          </a:prstGeom>
+          <a:noFill/>
+        </p:spPr>
+        <p:txBody>
+          <a:bodyPr wrap="square" lIns="0" rIns="0" tIns="0" bIns="0" anchor="ctr">
+            <a:noAutofit/>
+          </a:bodyPr>
+          <a:lstStyle/>
+          <a:p>
+            <a:pPr algn="ctr">
+              <a:lnSpc>
+                <a:spcPct val="108000"/>
+              </a:lnSpc>
+              <a:spcAft>
+                <a:spcPts val="0"/>
+              </a:spcAft>
+            </a:pPr>
+            <a:r>
+              <a:rPr sz="1300" b="1" i="0">
+                <a:solidFill>
+                  <a:srgbClr val="FFFFFF"/>
+                </a:solidFill>
+                <a:latin typeface="Calibri"/>
+              </a:rPr>
+              <a:t>TM</a:t>
+            </a:r>
+          </a:p>
+        </p:txBody>
+      </p:sp>
+      <p:sp>
+        <p:nvSpPr>
+          <p:cNvPr id="19" name="TextBox 18"/>
+          <p:cNvSpPr txBox="1"/>
+          <p:nvPr/>
+        </p:nvSpPr>
+        <p:spPr>
+          <a:xfrm>
+            <a:off x="5276088" y="3218688"/>
+            <a:ext cx="1810512" cy="438912"/>
+          </a:xfrm>
+          <a:prstGeom prst="rect">
+            <a:avLst/>
+          </a:prstGeom>
+          <a:noFill/>
+        </p:spPr>
+        <p:txBody>
+          <a:bodyPr wrap="square" lIns="0" rIns="0" tIns="0" bIns="0" anchor="t">
+            <a:noAutofit/>
+          </a:bodyPr>
+          <a:lstStyle/>
+          <a:p>
+            <a:pPr algn="l">
+              <a:lnSpc>
+                <a:spcPct val="100000"/>
+              </a:lnSpc>
+              <a:spcAft>
+                <a:spcPts val="0"/>
+              </a:spcAft>
+            </a:pPr>
+            <a:r>
+              <a:rPr sz="1140" b="1" i="0">
+                <a:solidFill>
+                  <a:srgbClr val="FFFFFF"/>
+                </a:solidFill>
+                <a:latin typeface="Calibri"/>
+              </a:rPr>
+              <a:t>[Team member 3]</a:t>
+            </a:r>
+          </a:p>
+        </p:txBody>
+      </p:sp>
+      <p:sp>
+        <p:nvSpPr>
+          <p:cNvPr id="20" name="TextBox 19"/>
+          <p:cNvSpPr txBox="1"/>
+          <p:nvPr/>
+        </p:nvSpPr>
+        <p:spPr>
+          <a:xfrm>
+            <a:off x="5276088" y="3675887"/>
+            <a:ext cx="1810512" cy="576072"/>
+          </a:xfrm>
+          <a:prstGeom prst="rect">
+            <a:avLst/>
+          </a:prstGeom>
+          <a:noFill/>
+        </p:spPr>
+        <p:txBody>
+          <a:bodyPr wrap="square" lIns="0" rIns="0" tIns="0" bIns="0" anchor="t">
+            <a:noAutofit/>
+          </a:bodyPr>
+          <a:lstStyle/>
+          <a:p>
+            <a:pPr algn="l">
+              <a:lnSpc>
+                <a:spcPct val="108000"/>
+              </a:lnSpc>
+              <a:spcAft>
+                <a:spcPts val="0"/>
+              </a:spcAft>
+            </a:pPr>
+            <a:r>
+              <a:rPr sz="880" b="1" i="0">
+                <a:solidFill>
+                  <a:srgbClr val="8B5CF6"/>
+                </a:solidFill>
+                <a:latin typeface="Calibri"/>
+              </a:rPr>
+              <a:t>[Role / specialty]</a:t>
+            </a:r>
+          </a:p>
+        </p:txBody>
+      </p:sp>
+      <p:sp>
+        <p:nvSpPr>
+          <p:cNvPr id="21" name="TextBox 20"/>
+          <p:cNvSpPr txBox="1"/>
+          <p:nvPr/>
+        </p:nvSpPr>
+        <p:spPr>
+          <a:xfrm>
+            <a:off x="5276088" y="4315968"/>
+            <a:ext cx="1810512" cy="896112"/>
+          </a:xfrm>
+          <a:prstGeom prst="rect">
+            <a:avLst/>
+          </a:prstGeom>
+          <a:noFill/>
+        </p:spPr>
+        <p:txBody>
+          <a:bodyPr wrap="square" lIns="0" rIns="0" tIns="0" bIns="0" anchor="t">
+            <a:noAutofit/>
+          </a:bodyPr>
+          <a:lstStyle/>
+          <a:p>
+            <a:pPr algn="l">
+              <a:lnSpc>
+                <a:spcPct val="113000"/>
+              </a:lnSpc>
+              <a:spcAft>
+                <a:spcPts val="0"/>
+              </a:spcAft>
+            </a:pPr>
+            <a:r>
+              <a:rPr sz="880" b="0" i="0">
+                <a:solidFill>
+                  <a:srgbClr val="A9A9C7"/>
+                </a:solidFill>
+                <a:latin typeface="Calibri"/>
+              </a:rPr>
+              <a:t>Add their contribution or one shipped proof point.</a:t>
+            </a:r>
+          </a:p>
+        </p:txBody>
+      </p:sp>
+      <p:sp>
+        <p:nvSpPr>
+          <p:cNvPr id="22" name="Rounded Rectangle 21"/>
+          <p:cNvSpPr/>
+          <p:nvPr/>
+        </p:nvSpPr>
+        <p:spPr>
+          <a:xfrm>
+            <a:off x="7415783" y="2103120"/>
+            <a:ext cx="2139696" cy="3310128"/>
+          </a:xfrm>
+          <a:prstGeom prst="roundRect">
+            <a:avLst>
+              <a:gd name="adj" fmla="val 6837"/>
+            </a:avLst>
+          </a:prstGeom>
+          <a:solidFill>
+            <a:srgbClr val="1B1A3F"/>
+          </a:solidFill>
+          <a:ln>
+            <a:noFill/>
+          </a:ln>
+          <a:effectLst/>
+        </p:spPr>
+        <p:style>
+          <a:lnRef idx="1">
+            <a:schemeClr val="accent1"/>
+          </a:lnRef>
+          <a:fillRef idx="3">
+            <a:schemeClr val="accent1"/>
+          </a:fillRef>
+          <a:effectRef idx="2">
+            <a:schemeClr val="accent1"/>
+          </a:effectRef>
+          <a:fontRef idx="minor">
+            <a:schemeClr val="lt1"/>
+          </a:fontRef>
+        </p:style>
+        <p:txBody>
+          <a:bodyPr rtlCol="0" anchor="ctr"/>
+          <a:lstStyle/>
+          <a:p/>
+        </p:txBody>
+      </p:sp>
+      <p:sp>
+        <p:nvSpPr>
+          <p:cNvPr id="23" name="Oval 22"/>
+          <p:cNvSpPr/>
+          <p:nvPr/>
+        </p:nvSpPr>
+        <p:spPr>
+          <a:xfrm>
+            <a:off x="8138159" y="2414016"/>
+            <a:ext cx="694944" cy="694944"/>
           </a:xfrm>
           <a:prstGeom prst="ellipse">
             <a:avLst/>
@@ -25220,14 +25479,14 @@
       </p:sp>
       <p:sp>
         <p:nvSpPr>
-          <p:cNvPr id="18" name="TextBox 17"/>
-          <p:cNvSpPr txBox="1"/>
-          <p:nvPr/>
-        </p:nvSpPr>
-        <p:spPr>
-          <a:xfrm>
-            <a:off x="6473951" y="2331720"/>
-            <a:ext cx="822960" cy="822960"/>
+          <p:cNvPr id="24" name="TextBox 23"/>
+          <p:cNvSpPr txBox="1"/>
+          <p:nvPr/>
+        </p:nvSpPr>
+        <p:spPr>
+          <a:xfrm>
+            <a:off x="8138159" y="2414016"/>
+            <a:ext cx="694944" cy="694944"/>
           </a:xfrm>
           <a:prstGeom prst="rect">
             <a:avLst/>
@@ -25249,7 +25508,7 @@
               </a:spcAft>
             </a:pPr>
             <a:r>
-              <a:rPr sz="1600" b="1" i="0">
+              <a:rPr sz="1300" b="1" i="0">
                 <a:solidFill>
                   <a:srgbClr val="0F0E2A"/>
                 </a:solidFill>
@@ -25262,14 +25521,14 @@
       </p:sp>
       <p:sp>
         <p:nvSpPr>
-          <p:cNvPr id="19" name="TextBox 18"/>
-          <p:cNvSpPr txBox="1"/>
-          <p:nvPr/>
-        </p:nvSpPr>
-        <p:spPr>
-          <a:xfrm>
-            <a:off x="6473951" y="3383280"/>
-            <a:ext cx="2057400" cy="365760"/>
+          <p:cNvPr id="25" name="TextBox 24"/>
+          <p:cNvSpPr txBox="1"/>
+          <p:nvPr/>
+        </p:nvSpPr>
+        <p:spPr>
+          <a:xfrm>
+            <a:off x="7580375" y="3218688"/>
+            <a:ext cx="1810512" cy="438912"/>
           </a:xfrm>
           <a:prstGeom prst="rect">
             <a:avLst/>
@@ -25284,6 +25543,48 @@
           <a:p>
             <a:pPr algn="l">
               <a:lnSpc>
+                <a:spcPct val="100000"/>
+              </a:lnSpc>
+              <a:spcAft>
+                <a:spcPts val="0"/>
+              </a:spcAft>
+            </a:pPr>
+            <a:r>
+              <a:rPr sz="1140" b="1" i="0">
+                <a:solidFill>
+                  <a:srgbClr val="FFFFFF"/>
+                </a:solidFill>
+                <a:latin typeface="Calibri"/>
+              </a:rPr>
+              <a:t>[Clinical advisor]</a:t>
+            </a:r>
+          </a:p>
+        </p:txBody>
+      </p:sp>
+      <p:sp>
+        <p:nvSpPr>
+          <p:cNvPr id="26" name="TextBox 25"/>
+          <p:cNvSpPr txBox="1"/>
+          <p:nvPr/>
+        </p:nvSpPr>
+        <p:spPr>
+          <a:xfrm>
+            <a:off x="7580375" y="3675887"/>
+            <a:ext cx="1810512" cy="576072"/>
+          </a:xfrm>
+          <a:prstGeom prst="rect">
+            <a:avLst/>
+          </a:prstGeom>
+          <a:noFill/>
+        </p:spPr>
+        <p:txBody>
+          <a:bodyPr wrap="square" lIns="0" rIns="0" tIns="0" bIns="0" anchor="t">
+            <a:noAutofit/>
+          </a:bodyPr>
+          <a:lstStyle/>
+          <a:p>
+            <a:pPr algn="l">
+              <a:lnSpc>
                 <a:spcPct val="108000"/>
               </a:lnSpc>
               <a:spcAft>
@@ -25291,27 +25592,27 @@
               </a:spcAft>
             </a:pPr>
             <a:r>
-              <a:rPr sz="1400" b="1" i="0">
-                <a:solidFill>
-                  <a:srgbClr val="FFFFFF"/>
-                </a:solidFill>
-                <a:latin typeface="Calibri"/>
-              </a:rPr>
-              <a:t>[Clinical advisor]</a:t>
-            </a:r>
-          </a:p>
-        </p:txBody>
-      </p:sp>
-      <p:sp>
-        <p:nvSpPr>
-          <p:cNvPr id="20" name="TextBox 19"/>
-          <p:cNvSpPr txBox="1"/>
-          <p:nvPr/>
-        </p:nvSpPr>
-        <p:spPr>
-          <a:xfrm>
-            <a:off x="6473951" y="3730752"/>
-            <a:ext cx="2057400" cy="548640"/>
+              <a:rPr sz="880" b="1" i="0">
+                <a:solidFill>
+                  <a:srgbClr val="22D3EE"/>
+                </a:solidFill>
+                <a:latin typeface="Calibri"/>
+              </a:rPr>
+              <a:t>Geriatrics / family medicine — recruiting</a:t>
+            </a:r>
+          </a:p>
+        </p:txBody>
+      </p:sp>
+      <p:sp>
+        <p:nvSpPr>
+          <p:cNvPr id="27" name="TextBox 26"/>
+          <p:cNvSpPr txBox="1"/>
+          <p:nvPr/>
+        </p:nvSpPr>
+        <p:spPr>
+          <a:xfrm>
+            <a:off x="7580375" y="4315968"/>
+            <a:ext cx="1810512" cy="896112"/>
           </a:xfrm>
           <a:prstGeom prst="rect">
             <a:avLst/>
@@ -25326,56 +25627,14 @@
           <a:p>
             <a:pPr algn="l">
               <a:lnSpc>
-                <a:spcPct val="115000"/>
-              </a:lnSpc>
-              <a:spcAft>
-                <a:spcPts val="0"/>
-              </a:spcAft>
-            </a:pPr>
-            <a:r>
-              <a:rPr sz="1000" b="1" i="0">
-                <a:solidFill>
-                  <a:srgbClr val="22D3EE"/>
-                </a:solidFill>
-                <a:latin typeface="Calibri"/>
-              </a:rPr>
-              <a:t>Geriatrics / family medicine — recruiting</a:t>
-            </a:r>
-          </a:p>
-        </p:txBody>
-      </p:sp>
-      <p:sp>
-        <p:nvSpPr>
-          <p:cNvPr id="21" name="TextBox 20"/>
-          <p:cNvSpPr txBox="1"/>
-          <p:nvPr/>
-        </p:nvSpPr>
-        <p:spPr>
-          <a:xfrm>
-            <a:off x="6473951" y="4297680"/>
-            <a:ext cx="2057400" cy="914400"/>
-          </a:xfrm>
-          <a:prstGeom prst="rect">
-            <a:avLst/>
-          </a:prstGeom>
-          <a:noFill/>
-        </p:spPr>
-        <p:txBody>
-          <a:bodyPr wrap="square" lIns="0" rIns="0" tIns="0" bIns="0" anchor="t">
-            <a:noAutofit/>
-          </a:bodyPr>
-          <a:lstStyle/>
-          <a:p>
-            <a:pPr algn="l">
-              <a:lnSpc>
-                <a:spcPct val="120000"/>
-              </a:lnSpc>
-              <a:spcAft>
-                <a:spcPts val="0"/>
-              </a:spcAft>
-            </a:pPr>
-            <a:r>
-              <a:rPr sz="1000" b="0" i="0">
+                <a:spcPct val="113000"/>
+              </a:lnSpc>
+              <a:spcAft>
+                <a:spcPts val="0"/>
+              </a:spcAft>
+            </a:pPr>
+            <a:r>
+              <a:rPr sz="880" b="0" i="0">
                 <a:solidFill>
                   <a:srgbClr val="A9A9C7"/>
                 </a:solidFill>
@@ -25388,18 +25647,18 @@
       </p:sp>
       <p:sp>
         <p:nvSpPr>
-          <p:cNvPr id="22" name="Rounded Rectangle 21"/>
+          <p:cNvPr id="28" name="Rounded Rectangle 27"/>
           <p:cNvSpPr/>
           <p:nvPr/>
         </p:nvSpPr>
         <p:spPr>
           <a:xfrm>
-            <a:off x="9025128" y="2103120"/>
-            <a:ext cx="2606040" cy="3200400"/>
+            <a:off x="9720072" y="2103120"/>
+            <a:ext cx="2139696" cy="3310128"/>
           </a:xfrm>
           <a:prstGeom prst="roundRect">
             <a:avLst>
-              <a:gd name="adj" fmla="val 5614"/>
+              <a:gd name="adj" fmla="val 6837"/>
             </a:avLst>
           </a:prstGeom>
           <a:solidFill>
@@ -25432,14 +25691,14 @@
       </p:sp>
       <p:sp>
         <p:nvSpPr>
-          <p:cNvPr id="23" name="Oval 22"/>
+          <p:cNvPr id="29" name="Oval 28"/>
           <p:cNvSpPr/>
           <p:nvPr/>
         </p:nvSpPr>
         <p:spPr>
           <a:xfrm>
-            <a:off x="9299448" y="2331720"/>
-            <a:ext cx="822960" cy="822960"/>
+            <a:off x="10442447" y="2414016"/>
+            <a:ext cx="694944" cy="694944"/>
           </a:xfrm>
           <a:prstGeom prst="ellipse">
             <a:avLst/>
@@ -25474,14 +25733,14 @@
       </p:sp>
       <p:sp>
         <p:nvSpPr>
-          <p:cNvPr id="24" name="TextBox 23"/>
-          <p:cNvSpPr txBox="1"/>
-          <p:nvPr/>
-        </p:nvSpPr>
-        <p:spPr>
-          <a:xfrm>
-            <a:off x="9299448" y="2331720"/>
-            <a:ext cx="822960" cy="822960"/>
+          <p:cNvPr id="30" name="TextBox 29"/>
+          <p:cNvSpPr txBox="1"/>
+          <p:nvPr/>
+        </p:nvSpPr>
+        <p:spPr>
+          <a:xfrm>
+            <a:off x="10442447" y="2414016"/>
+            <a:ext cx="694944" cy="694944"/>
           </a:xfrm>
           <a:prstGeom prst="rect">
             <a:avLst/>
@@ -25503,7 +25762,7 @@
               </a:spcAft>
             </a:pPr>
             <a:r>
-              <a:rPr sz="1600" b="1" i="0">
+              <a:rPr sz="1300" b="1" i="0">
                 <a:solidFill>
                   <a:srgbClr val="0F0E2A"/>
                 </a:solidFill>
@@ -25516,14 +25775,14 @@
       </p:sp>
       <p:sp>
         <p:nvSpPr>
-          <p:cNvPr id="25" name="TextBox 24"/>
-          <p:cNvSpPr txBox="1"/>
-          <p:nvPr/>
-        </p:nvSpPr>
-        <p:spPr>
-          <a:xfrm>
-            <a:off x="9299448" y="3383280"/>
-            <a:ext cx="2057400" cy="365760"/>
+          <p:cNvPr id="31" name="TextBox 30"/>
+          <p:cNvSpPr txBox="1"/>
+          <p:nvPr/>
+        </p:nvSpPr>
+        <p:spPr>
+          <a:xfrm>
+            <a:off x="9884663" y="3218688"/>
+            <a:ext cx="1810512" cy="438912"/>
           </a:xfrm>
           <a:prstGeom prst="rect">
             <a:avLst/>
@@ -25538,6 +25797,48 @@
           <a:p>
             <a:pPr algn="l">
               <a:lnSpc>
+                <a:spcPct val="100000"/>
+              </a:lnSpc>
+              <a:spcAft>
+                <a:spcPts val="0"/>
+              </a:spcAft>
+            </a:pPr>
+            <a:r>
+              <a:rPr sz="1140" b="1" i="0">
+                <a:solidFill>
+                  <a:srgbClr val="FFFFFF"/>
+                </a:solidFill>
+                <a:latin typeface="Calibri"/>
+              </a:rPr>
+              <a:t>[Growth lead]</a:t>
+            </a:r>
+          </a:p>
+        </p:txBody>
+      </p:sp>
+      <p:sp>
+        <p:nvSpPr>
+          <p:cNvPr id="32" name="TextBox 31"/>
+          <p:cNvSpPr txBox="1"/>
+          <p:nvPr/>
+        </p:nvSpPr>
+        <p:spPr>
+          <a:xfrm>
+            <a:off x="9884663" y="3675887"/>
+            <a:ext cx="1810512" cy="576072"/>
+          </a:xfrm>
+          <a:prstGeom prst="rect">
+            <a:avLst/>
+          </a:prstGeom>
+          <a:noFill/>
+        </p:spPr>
+        <p:txBody>
+          <a:bodyPr wrap="square" lIns="0" rIns="0" tIns="0" bIns="0" anchor="t">
+            <a:noAutofit/>
+          </a:bodyPr>
+          <a:lstStyle/>
+          <a:p>
+            <a:pPr algn="l">
+              <a:lnSpc>
                 <a:spcPct val="108000"/>
               </a:lnSpc>
               <a:spcAft>
@@ -25545,27 +25846,27 @@
               </a:spcAft>
             </a:pPr>
             <a:r>
-              <a:rPr sz="1400" b="1" i="0">
-                <a:solidFill>
-                  <a:srgbClr val="FFFFFF"/>
-                </a:solidFill>
-                <a:latin typeface="Calibri"/>
-              </a:rPr>
-              <a:t>[Growth lead]</a:t>
-            </a:r>
-          </a:p>
-        </p:txBody>
-      </p:sp>
-      <p:sp>
-        <p:nvSpPr>
-          <p:cNvPr id="26" name="TextBox 25"/>
-          <p:cNvSpPr txBox="1"/>
-          <p:nvPr/>
-        </p:nvSpPr>
-        <p:spPr>
-          <a:xfrm>
-            <a:off x="9299448" y="3730752"/>
-            <a:ext cx="2057400" cy="548640"/>
+              <a:rPr sz="880" b="1" i="0">
+                <a:solidFill>
+                  <a:srgbClr val="34D399"/>
+                </a:solidFill>
+                <a:latin typeface="Calibri"/>
+              </a:rPr>
+              <a:t>Partnerships &amp; go-to-market — recruiting</a:t>
+            </a:r>
+          </a:p>
+        </p:txBody>
+      </p:sp>
+      <p:sp>
+        <p:nvSpPr>
+          <p:cNvPr id="33" name="TextBox 32"/>
+          <p:cNvSpPr txBox="1"/>
+          <p:nvPr/>
+        </p:nvSpPr>
+        <p:spPr>
+          <a:xfrm>
+            <a:off x="9884663" y="4315968"/>
+            <a:ext cx="1810512" cy="896112"/>
           </a:xfrm>
           <a:prstGeom prst="rect">
             <a:avLst/>
@@ -25580,56 +25881,14 @@
           <a:p>
             <a:pPr algn="l">
               <a:lnSpc>
-                <a:spcPct val="115000"/>
-              </a:lnSpc>
-              <a:spcAft>
-                <a:spcPts val="0"/>
-              </a:spcAft>
-            </a:pPr>
-            <a:r>
-              <a:rPr sz="1000" b="1" i="0">
-                <a:solidFill>
-                  <a:srgbClr val="34D399"/>
-                </a:solidFill>
-                <a:latin typeface="Calibri"/>
-              </a:rPr>
-              <a:t>Partnerships &amp; go-to-market — recruiting</a:t>
-            </a:r>
-          </a:p>
-        </p:txBody>
-      </p:sp>
-      <p:sp>
-        <p:nvSpPr>
-          <p:cNvPr id="27" name="TextBox 26"/>
-          <p:cNvSpPr txBox="1"/>
-          <p:nvPr/>
-        </p:nvSpPr>
-        <p:spPr>
-          <a:xfrm>
-            <a:off x="9299448" y="4297680"/>
-            <a:ext cx="2057400" cy="914400"/>
-          </a:xfrm>
-          <a:prstGeom prst="rect">
-            <a:avLst/>
-          </a:prstGeom>
-          <a:noFill/>
-        </p:spPr>
-        <p:txBody>
-          <a:bodyPr wrap="square" lIns="0" rIns="0" tIns="0" bIns="0" anchor="t">
-            <a:noAutofit/>
-          </a:bodyPr>
-          <a:lstStyle/>
-          <a:p>
-            <a:pPr algn="l">
-              <a:lnSpc>
-                <a:spcPct val="120000"/>
-              </a:lnSpc>
-              <a:spcAft>
-                <a:spcPts val="0"/>
-              </a:spcAft>
-            </a:pPr>
-            <a:r>
-              <a:rPr sz="1000" b="0" i="0">
+                <a:spcPct val="113000"/>
+              </a:lnSpc>
+              <a:spcAft>
+                <a:spcPts val="0"/>
+              </a:spcAft>
+            </a:pPr>
+            <a:r>
+              <a:rPr sz="880" b="0" i="0">
                 <a:solidFill>
                   <a:srgbClr val="A9A9C7"/>
                 </a:solidFill>
@@ -25642,7 +25901,7 @@
       </p:sp>
       <p:sp>
         <p:nvSpPr>
-          <p:cNvPr id="28" name="TextBox 27"/>
+          <p:cNvPr id="34" name="TextBox 33"/>
           <p:cNvSpPr txBox="1"/>
           <p:nvPr/>
         </p:nvSpPr>
@@ -25677,14 +25936,14 @@
                 </a:solidFill>
                 <a:latin typeface="Calibri"/>
               </a:rPr>
-              <a:t>Replace the bracketed placeholders with names, photos and one proof point each (previous product shipped, publication, clinical role).</a:t>
-            </a:r>
-          </a:p>
-        </p:txBody>
-      </p:sp>
-      <p:sp>
-        <p:nvSpPr>
-          <p:cNvPr id="29" name="TextBox 28"/>
+              <a:t>Customize card 3 with the fifth teammate’s name, photo and one proof point.</a:t>
+            </a:r>
+          </a:p>
+        </p:txBody>
+      </p:sp>
+      <p:sp>
+        <p:nvSpPr>
+          <p:cNvPr id="35" name="TextBox 34"/>
           <p:cNvSpPr txBox="1"/>
           <p:nvPr/>
         </p:nvSpPr>
@@ -25735,7 +25994,7 @@
       </p:sp>
       <p:sp>
         <p:nvSpPr>
-          <p:cNvPr id="30" name="TextBox 29"/>
+          <p:cNvPr id="36" name="TextBox 35"/>
           <p:cNvSpPr txBox="1"/>
           <p:nvPr/>
         </p:nvSpPr>

</xml_diff>